<commit_message>
adding final jeopardy review
</commit_message>
<xml_diff>
--- a/exam/final/Final_Jeopardy.pptx
+++ b/exam/final/Final_Jeopardy.pptx
@@ -4538,12 +4538,6 @@
             <a:r>
               <a:rPr lang="en-US" dirty="0"/>
               <a:t>Reminder that HW 15 is due tonight by midnight</a:t>
-            </a:r>
-          </a:p>
-          <a:p>
-            <a:r>
-              <a:rPr lang="en-US" dirty="0"/>
-              <a:t>The late assignment deadline for HW 14 is today at noon</a:t>
             </a:r>
           </a:p>
           <a:p>

</xml_diff>